<commit_message>
Update the docs and the deck for phone calls, email and domain scope
Co-Authored-By: Claude Sonnet 5.5 <noreply@anthropic.com>
</commit_message>
<xml_diff>
--- a/Paytm_AI_Teammate.pptx
+++ b/Paytm_AI_Teammate.pptx
@@ -3194,7 +3194,7 @@
                 </a:solidFill>
                 <a:latin typeface="Arial"/>
               </a:rPr>
-              <a:t>Track 3: Autonomous AI Teammates  |  Resolving merchant support tickets end to end</a:t>
+              <a:t>Track 3: Autonomous AI Teammates  |  Resolving merchant support calls end to end</a:t>
             </a:r>
           </a:p>
         </p:txBody>
@@ -3936,7 +3936,7 @@
                 </a:solidFill>
                 <a:latin typeface="Arial"/>
               </a:rPr>
-              <a:t>As a Paytm merchant, I want my settlement, refund or device issue fixed in one chat, so my shop keeps running without waiting on a call-back.</a:t>
+              <a:t>As a Paytm merchant, I want my settlement, refund or device issue fixed on one call, so my shop keeps running and I get a confirmation email.</a:t>
             </a:r>
           </a:p>
         </p:txBody>
@@ -4115,7 +4115,7 @@
                 </a:solidFill>
                 <a:latin typeface="Arial"/>
               </a:rPr>
-              <a:t>As a support agent, I want only the risky or unclear cases, with the full story and a recommendation, so I never re-ask the merchant.</a:t>
+              <a:t>As a support agent, I want risky cases and emergencies with the full story and a recommendation, so I never re-ask the merchant.</a:t>
             </a:r>
           </a:p>
         </p:txBody>
@@ -4416,7 +4416,7 @@
                 </a:solidFill>
                 <a:latin typeface="Arial"/>
               </a:rPr>
-              <a:t>Customer service</a:t>
+              <a:t>Customer support calls</a:t>
             </a:r>
           </a:p>
         </p:txBody>
@@ -4650,7 +4650,7 @@
                 </a:solidFill>
                 <a:latin typeface="Arial"/>
               </a:rPr>
-              <a:t>Simulated for the demo</a:t>
+              <a:t>Simulated; live voice, email</a:t>
             </a:r>
           </a:p>
         </p:txBody>
@@ -5644,7 +5644,7 @@
                 </a:solidFill>
                 <a:latin typeface="Arial"/>
               </a:rPr>
-              <a:t>An AI teammate that closes the ticket, not just replies to it, and hands over to a human only when it should.</a:t>
+              <a:t>An AI teammate that answers the call, closes the ticket, and hands over to a human only when it should.</a:t>
             </a:r>
           </a:p>
         </p:txBody>
@@ -6181,7 +6181,7 @@
                 </a:solidFill>
                 <a:latin typeface="Arial"/>
               </a:rPr>
-              <a:t>Refunds within limits, raises device replacements, notifies the merchant.</a:t>
+              <a:t>Refunds within limits, raises replacements, emails a confirmation.</a:t>
             </a:r>
           </a:p>
         </p:txBody>
@@ -6360,7 +6360,7 @@
                 </a:solidFill>
                 <a:latin typeface="Arial"/>
               </a:rPr>
-              <a:t>Sends risky cases with a summary, steps tried and a recommendation.</a:t>
+              <a:t>Sends risky cases and emergencies, with summary, steps tried and advice.</a:t>
             </a:r>
           </a:p>
         </p:txBody>
@@ -6631,7 +6631,7 @@
                 </a:solidFill>
                 <a:latin typeface="Arial"/>
               </a:rPr>
-              <a:t>Merchant raises ticket</a:t>
+              <a:t>Merchant call opens ticket</a:t>
             </a:r>
           </a:p>
         </p:txBody>
@@ -7001,7 +7001,7 @@
                 </a:solidFill>
                 <a:latin typeface="Arial"/>
               </a:rPr>
-              <a:t>One refund per transaction.</a:t>
+              <a:t>One refund per transaction. Stays in its domain.</a:t>
             </a:r>
           </a:p>
           <a:p>
@@ -7017,7 +7017,7 @@
                 </a:solidFill>
                 <a:latin typeface="Arial"/>
               </a:rPr>
-              <a:t>Merchant id comes from the ticket, never from the model.</a:t>
+              <a:t>Merchant id comes from the call, never from the model.</a:t>
             </a:r>
           </a:p>
         </p:txBody>
@@ -7226,7 +7226,7 @@
                 </a:solidFill>
                 <a:latin typeface="Arial"/>
               </a:rPr>
-              <a:t>Failed payment, customer debited, small amount: refund and notify</a:t>
+              <a:t>Failed payment, debited, small amount: refund and email confirmation</a:t>
             </a:r>
           </a:p>
         </p:txBody>
@@ -7470,7 +7470,7 @@
                 </a:solidFill>
                 <a:latin typeface="Arial"/>
               </a:rPr>
-              <a:t>High-value refund, KYC hold, fraud: human with full context</a:t>
+              <a:t>Large refund, KYC hold, fraud: human alerted with full context</a:t>
             </a:r>
           </a:p>
         </p:txBody>
@@ -7814,7 +7814,7 @@
                 </a:solidFill>
                 <a:latin typeface="Arial"/>
               </a:rPr>
-              <a:t>Groq, gpt-oss-120b</a:t>
+              <a:t>NVIDIA Nemotron 120B</a:t>
             </a:r>
           </a:p>
         </p:txBody>
@@ -8018,7 +8018,7 @@
                 </a:solidFill>
                 <a:latin typeface="Arial"/>
               </a:rPr>
-              <a:t>Agent loop, guarded tools, REST API</a:t>
+              <a:t>Guarded tools, voice webhooks, REST API</a:t>
             </a:r>
           </a:p>
         </p:txBody>
@@ -8348,7 +8348,7 @@
                 </a:solidFill>
                 <a:latin typeface="Arial"/>
               </a:rPr>
-              <a:t>Merchant chat and ops console</a:t>
+              <a:t>Merchant call screen and ops console</a:t>
             </a:r>
           </a:p>
         </p:txBody>
@@ -8639,7 +8639,7 @@
                 </a:solidFill>
                 <a:latin typeface="Arial"/>
               </a:rPr>
-              <a:t>Simulated services</a:t>
+              <a:t>Bolna voice, Resend email</a:t>
             </a:r>
           </a:p>
         </p:txBody>
@@ -8678,7 +8678,7 @@
                 </a:solidFill>
                 <a:latin typeface="Arial"/>
               </a:rPr>
-              <a:t>Payments, settlements, devices, notifications</a:t>
+              <a:t>Payments, settlements, devices simulated</a:t>
             </a:r>
           </a:p>
         </p:txBody>
@@ -9956,7 +9956,7 @@
                 </a:solidFill>
                 <a:latin typeface="Arial"/>
               </a:rPr>
-              <a:t>Issue handled in one conversation</a:t>
+              <a:t>Issue handled in one phone call</a:t>
             </a:r>
           </a:p>
           <a:p>
@@ -9988,7 +9988,7 @@
                 </a:solidFill>
                 <a:latin typeface="Arial"/>
               </a:rPr>
-              <a:t>Clear status, no chasing</a:t>
+              <a:t>Email confirmation, no chasing</a:t>
             </a:r>
           </a:p>
         </p:txBody>
@@ -10343,7 +10343,7 @@
                 </a:solidFill>
                 <a:latin typeface="Arial"/>
               </a:rPr>
-              <a:t>DEMO TARGETS, MEASURED BY OUR EVAL RUN (NOT CLAIMED RESULTS)</a:t>
+              <a:t>MEASURED IN OUR 12-SCENARIO EVAL RUN, NOT CLAIMED</a:t>
             </a:r>
           </a:p>
         </p:txBody>
@@ -10426,7 +10426,7 @@
                 </a:solidFill>
                 <a:latin typeface="Arial"/>
               </a:rPr>
-              <a:t>70%+</a:t>
+              <a:t>12/12</a:t>
             </a:r>
           </a:p>
         </p:txBody>
@@ -10465,7 +10465,7 @@
                 </a:solidFill>
                 <a:latin typeface="Arial"/>
               </a:rPr>
-              <a:t>tickets auto-resolved</a:t>
+              <a:t>eval decisions correct</a:t>
             </a:r>
           </a:p>
         </p:txBody>
@@ -10670,7 +10670,7 @@
                 </a:solidFill>
                 <a:latin typeface="Arial"/>
               </a:rPr>
-              <a:t>&lt;30 s</a:t>
+              <a:t>4-40 s</a:t>
             </a:r>
           </a:p>
         </p:txBody>
@@ -11553,7 +11553,7 @@
                 </a:solidFill>
                 <a:latin typeface="Arial"/>
               </a:rPr>
-              <a:t>More ticket types, sales workflows, regional languages, other platforms.</a:t>
+              <a:t>More ticket types, sales workflows, more Indian languages, other platforms.</a:t>
             </a:r>
           </a:p>
         </p:txBody>

</xml_diff>